<commit_message>
Final validated AMMX training decks (49), instructor guides and work instruction PDFs (30)
- All 49 decks validated by technical, safety, labor and documentation experts
- 30 role-based work instructions with figures, diagrams and STOP boxes
- Optimized figure PNGs; IT download ZIP (presentations ZIP kept out of git)

Co-Authored-By: Claude Opus 5.5 <noreply@anthropic.com>
Claude-Session: https://claude.ai/code/session_01KNk188BQs5d5yrXcfpDDFP
</commit_message>
<xml_diff>
--- a/10-plantas/01-steelmaking/05-capacitacion/MM-CC-01/MM-CC-01_Capacitacion_AMMX.pptx
+++ b/10-plantas/01-steelmaking/05-capacitacion/MM-CC-01/MM-CC-01_Capacitacion_AMMX.pptx
@@ -3673,7 +3673,7 @@
                 <a:ea typeface="Century Gothic" pitchFamily="34" charset="-122"/>
                 <a:cs typeface="Century Gothic" pitchFamily="34" charset="-120"/>
               </a:rPr>
-              <a:t>Para: S-25 Mecánico de Taller · S-19 Mecánico · S-21 Instrumentista · S-22 · S-20 · operador de grúa de CC · C-16 (ESR)</a:t>
+              <a:t>Para: S-25 Mecánico de Taller · S-19 Mecánico · S-21 Instrumentista · S-22 Técnico Hidráulico · S-20 Electricista · Grúa de CC 50 t (hoy S-15) · C-11 · C-06 · C-16 (ESR)</a:t>
             </a:r>
             <a:endParaRPr lang="en-US" sz="1100" dirty="0"/>
           </a:p>
@@ -16141,7 +16141,7 @@
                           <a:ea typeface="Century Gothic" pitchFamily="34" charset="-122"/>
                           <a:cs typeface="Century Gothic" pitchFamily="34" charset="-120"/>
                         </a:rPr>
-                        <a:t>24 meses</a:t>
+                        <a:t>24 meses; POE 12</a:t>
                       </a:r>
                       <a:endParaRPr lang="en-US" sz="950" dirty="0">
                         <a:latin typeface="Century Gothic" charset="0"/>
@@ -16895,7 +16895,7 @@
                           <a:ea typeface="Century Gothic" pitchFamily="34" charset="-122"/>
                           <a:cs typeface="Century Gothic" pitchFamily="34" charset="-120"/>
                         </a:rPr>
-                        <a:t>S-22 / S-20</a:t>
+                        <a:t>S-22 Hidráulico / S-20 Electricista</a:t>
                       </a:r>
                       <a:endParaRPr lang="en-US" sz="950" dirty="0">
                         <a:latin typeface="Century Gothic" charset="0"/>
@@ -17167,7 +17167,7 @@
                           <a:ea typeface="Century Gothic" pitchFamily="34" charset="-122"/>
                           <a:cs typeface="Century Gothic" pitchFamily="34" charset="-120"/>
                         </a:rPr>
-                        <a:t>24 / 12 meses</a:t>
+                        <a:t>S-22: 24 · S-20: 12 meses</a:t>
                       </a:r>
                       <a:endParaRPr lang="en-US" sz="950" dirty="0">
                         <a:latin typeface="Century Gothic" charset="0"/>
@@ -17237,7 +17237,7 @@
                           <a:ea typeface="Century Gothic" pitchFamily="34" charset="-122"/>
                           <a:cs typeface="Century Gothic" pitchFamily="34" charset="-120"/>
                         </a:rPr>
-                        <a:t>Operador de grúa de CC</a:t>
+                        <a:t>Grúa de CC (hoy S-15)</a:t>
                       </a:r>
                       <a:endParaRPr lang="en-US" sz="950" dirty="0">
                         <a:latin typeface="Century Gothic" charset="0"/>
@@ -19167,7 +19167,7 @@
                 <a:ea typeface="Century Gothic" pitchFamily="34" charset="-122"/>
                 <a:cs typeface="Century Gothic" pitchFamily="34" charset="-120"/>
               </a:rPr>
-              <a:t>24 meses</a:t>
+              <a:t>24 meses; POE 12</a:t>
             </a:r>
             <a:endParaRPr lang="en-US" sz="900" dirty="0"/>
           </a:p>
@@ -20853,7 +20853,7 @@
                 <a:ea typeface="Calibri" pitchFamily="34" charset="-122"/>
                 <a:cs typeface="Calibri" pitchFamily="34" charset="-120"/>
               </a:rPr>
-              <a:t>Siguiente paso: OJT supervisado y evaluación práctica (TD-P07); registro en IMaS y DC-3/SIRCE. Validación: pendiente.</a:t>
+              <a:t>Siguiente paso: OJT supervisado y evaluación práctica (TD-P07); registro en IMaS y DC-3/SIRCE. Validación: visto bueno técnica, seguridad, laboral, diseño instruccional.</a:t>
             </a:r>
             <a:endParaRPr lang="en-US" sz="750" dirty="0"/>
           </a:p>
@@ -23696,7 +23696,7 @@
                           <a:ea typeface="Century Gothic" pitchFamily="34" charset="-122"/>
                           <a:cs typeface="Century Gothic" pitchFamily="34" charset="-120"/>
                         </a:rPr>
-                        <a:t>S-22 / S-20</a:t>
+                        <a:t>S-22 Hidráulico / S-20 Electricista</a:t>
                       </a:r>
                       <a:endParaRPr lang="en-US" sz="1100" dirty="0">
                         <a:latin typeface="Century Gothic" charset="0"/>
@@ -23902,7 +23902,7 @@
                           <a:ea typeface="Century Gothic" pitchFamily="34" charset="-122"/>
                           <a:cs typeface="Century Gothic" pitchFamily="34" charset="-120"/>
                         </a:rPr>
-                        <a:t>Operador de grúa de CC (50 t)</a:t>
+                        <a:t>Grúa de CC 50 t (hoy S-15; S-27 propuesto)</a:t>
                       </a:r>
                       <a:endParaRPr lang="en-US" sz="1100" dirty="0">
                         <a:latin typeface="Century Gothic" charset="0"/>
@@ -25967,8 +25967,8 @@
         </p:blipFill>
         <p:spPr>
           <a:xfrm>
-            <a:off x="608729" y="1417320"/>
-            <a:ext cx="6646382" cy="4846320"/>
+            <a:off x="607463" y="1417320"/>
+            <a:ext cx="6648915" cy="4846320"/>
           </a:xfrm>
           <a:prstGeom prst="rect">
             <a:avLst/>

</xml_diff>